<commit_message>
Add the narration script and drive the speaker notes from it
The four per-slide scripts are written for text to speech: digits and
acronyms are spelled out, so 0.493 reads as "zero point four nine three".
451 words, about 167-180 seconds against the 3-minute limit.
make_slides.py now reads narration/ so the deck and the script cannot drift.
</commit_message>
<xml_diff>
--- a/report/APC_TDC_presentation.pptx
+++ b/report/APC_TDC_presentation.pptx
@@ -877,7 +877,7 @@
           <a:lstStyle/>
           <a:p>
             <a:r>
-              <a:t>[0:00-0:20] Hello. We are team APC underscore TDC, a one-person team from Schneider Electric Taiwan. We entered both categories. Category 1, weakly supervised tool detection, final mAP zero point four nine three. Category 2, surgical video question answering, BERTScore F1 zero point six one nine. Everything you will see is public: code, weights, and the report.</a:t>
+              <a:t>Hello. We are team A P C T D C, a one-person team from Schneider Electric Taiwan. We entered both categories. In Category One, weakly supervised tool detection, our final score was zero point four nine three. In Category Two, surgical video question answering, zero point six one nine.</a:t>
             </a:r>
           </a:p>
         </p:txBody>
@@ -947,7 +947,7 @@
           <a:lstStyle/>
           <a:p>
             <a:r>
-              <a:t>[0:20-1:20] The challenge gives us tool presence labels, not boxes. So the question is how to turn presence into localisation. Our answer is to use the presence label as a gate rather than as a target. We sample frames at one frame per second and crop them to the same geometry as the test set. A teacher ensemble of two RT-DETR models proposes boxes, and we fuse them with weighted box fusion. Then the gate: we keep only the frames where the number of boxes of each class is exactly equal to the number of that tool installed at that second, and where every box is above conf zero point three five. Twenty six percent of frames pass. We train a student on them, and that student becomes the next teacher, which raises the pass rate to forty one percent. The loop converges because the gate is external to the model.</a:t>
+              <a:t>The challenge gives us tool presence labels, not boxes. The question is how to turn presence into localisation. Our answer is to use the presence label as a gate, rather than as a target. We sample frames at one per second, and crop them to match the geometry of the test set. A teacher ensemble of two R T DETR models proposes boxes, and we fuse them with weighted box fusion. Then comes the gate. We keep only frames where the box count of each class exactly equals the number of that tool installed at that second, and every box is above confidence zero point three five. Twenty six percent of frames pass. We train a student on them, and that student becomes the next teacher, which raises the pass rate to forty one percent. The loop converges because the gate is external to the model.</a:t>
             </a:r>
           </a:p>
         </p:txBody>
@@ -1017,7 +1017,7 @@
           <a:lstStyle/>
           <a:p>
             <a:r>
-              <a:t>[1:20-2:20] Five decisions mattered. First, scale beats recipe. Going from twenty to two hundred eighty videos was worth plus zero point zero five two. Every recipe change we tried was worth at most zero point zero zero six. Second, let the weak label do the filtering; an exact count match is model independent, so the iteration does not drift. Third, never size-filter pseudo-labels: we tried, and it removed exactly the near and far field samples that carry the scale diversity. Fourth, and this one cost us the most: never keep a frame whose visible tool has no box. We excluded three classes from the targets but kept their images, and sixty five thousand frames taught the detector that a visible prograsp is background. Fifth, our remaining headroom was box tightness, not recall. Training at eight hundred pixels and fusing two resolutions were both worth more at AP75 than at AP50.</a:t>
+              <a:t>Five decisions mattered. First, scale beats recipe. Going from twenty videos to two hundred and eighty was worth plus zero point zero five two, while every recipe change we tried was worth at most zero point zero zero six. Second, let the weak label do the filtering. An exact count match is model independent, so the iteration does not drift. Third, never size filter your pseudo labels. It removes the near and far field samples that carry the scale diversity. Fourth, and this cost us the most, never keep a frame whose visible tool has no box. Sixty five thousand such frames taught our detector that a visible prograsp is background. Fifth, our remaining headroom was box tightness, not recall. Training at eight hundred pixels and fusing two resolutions both helped more at A P seventy five than at A P fifty.</a:t>
             </a:r>
           </a:p>
         </p:txBody>
@@ -1087,7 +1087,7 @@
           <a:lstStyle/>
           <a:p>
             <a:r>
-              <a:t>[2:20-3:00] Briefly, what did not work, because we think this is the more useful half. Thirty nine inference-time variants had a ceiling of half a point. Ten temporal post-processing variants were all negative. And the one that nearly fooled us: we read the robot interface with OCR to relabel the rare classes. On a tool-presence proxy metric it looked like a large win, from zero point five seven eight to zero point eight one nine. On real mAP it was negative. Two rulers, opposite directions. One honest caveat: our ablations hold out the student but not the teacher, so please read the paired differences, not the absolute numbers. Thank you.</a:t>
+              <a:t>What did not work, which we think is the more useful half. Thirty nine inference time variants had a ceiling of half a point. Ten temporal post processing variants were all negative. And the one that nearly fooled us. We read the robot interface with O C R to relabel the rare classes. On a tool presence proxy metric it looked like a large win, from zero point five seven eight to zero point eight one nine. On real mean A P it was negative. Two rulers, opposite directions. One honest caveat. Our ablations hold out the student but not the teacher, so please read the paired differences, not the absolute numbers. Thank you.</a:t>
             </a:r>
           </a:p>
         </p:txBody>

</xml_diff>

<commit_message>
Correct three misattributed figures in the deck, report and README
An audit against the experiment log found the +0.0376 AP75 gain was measured
on an s1 + R1v3 pair, both 640 px, not on the 640/800 fusion we submitted;
that combination is ALLGT and was never measured locally. The disclosure also
conflated two annotation sources: a large language model produced 2,096 frames from 718
annotated, while a further 202 grasping-retractor frames came from 32
hand-seeded boxes. AP50 0.93 is needle driver alone, not common classes.
</commit_message>
<xml_diff>
--- a/report/APC_TDC_presentation.pptx
+++ b/report/APC_TDC_presentation.pptx
@@ -947,7 +947,7 @@
           <a:lstStyle/>
           <a:p>
             <a:r>
-              <a:t>The challenge gives us tool presence labels, not boxes. The question is how to turn presence into localisation. Our answer is to use the presence label as a gate, rather than as a target. We sample frames at one per second, and crop them to match the geometry of the test set. A teacher ensemble of two R T DETR models proposes boxes, and we fuse them with weighted box fusion. Then comes the gate. We keep only frames where the box count of each class exactly equals the number of that tool installed at that second, and every box is above confidence zero point three five. Twenty six percent of frames pass. We train a student on them, and that student becomes the next teacher, which raises the pass rate to forty one percent. The loop converges because the gate is external to the model.</a:t>
+              <a:t>The challenge gives us tool presence labels, not boxes. Our answer is to use the presence label as a gate, rather than as a target. We sample frames at one per second, and crop them to match the geometry of the test set. A teacher ensemble of two R T DETR models proposes boxes, and we fuse them with weighted box fusion. Then comes the gate. We keep only frames where the box count of each class exactly equals the number of that tool installed at that second, and every box is above confidence zero point three five. Twenty six percent of frames pass. We train a student on them, and that student becomes the next teacher, which raises the pass rate to forty one percent. The loop converges because the gate is external to the model.</a:t>
             </a:r>
           </a:p>
         </p:txBody>
@@ -1017,7 +1017,7 @@
           <a:lstStyle/>
           <a:p>
             <a:r>
-              <a:t>Five decisions mattered. First, scale beats recipe. Going from twenty videos to two hundred and eighty was worth plus zero point zero five two, while every recipe change we tried was worth at most zero point zero zero six. Second, let the weak label do the filtering. An exact count match is model independent, so the iteration does not drift. Third, never size filter your pseudo labels. It removes the near and far field samples that carry the scale diversity. Fourth, and this cost us the most, never keep a frame whose visible tool has no box. Sixty five thousand such frames taught our detector that a visible prograsp is background. Fifth, our remaining headroom was box tightness, not recall. Training at eight hundred pixels and fusing two resolutions both helped more at A P seventy five than at A P fifty.</a:t>
+              <a:t>Five decisions mattered. First, scale beats recipe. Going from twenty videos to two hundred and eighty was worth plus zero point zero five two. Every recipe change we tried: at most zero point zero zero six. Second, let the weak label do the filtering. An exact count match is model independent, so the iteration does not drift. Third, never size filter your pseudo labels. It removes the near and far field samples that carry the scale diversity. Fourth, and this cost us the most, never keep a frame whose visible tool has no box. Sixty five thousand such frames taught our detector that a visible prograsp is background. Fifth, our remaining headroom was box tightness, not recall. Training at eight hundred pixels gave plus zero point zero two seven five at A P seventy five. Two model fusion gave plus zero point zero three seven six, though measured on a six forty pair, not on our submitted six forty plus eight hundred.</a:t>
             </a:r>
           </a:p>
         </p:txBody>
@@ -1087,7 +1087,7 @@
           <a:lstStyle/>
           <a:p>
             <a:r>
-              <a:t>What did not work, which we think is the more useful half. Thirty nine inference time variants had a ceiling of half a point. Ten temporal post processing variants were all negative. And the one that nearly fooled us. We read the robot interface with O C R to relabel the rare classes. On a tool presence proxy metric it looked like a large win, from zero point five seven eight to zero point eight one nine. On real mean A P it was negative. Two rulers, opposite directions. One honest caveat. Our ablations hold out the student but not the teacher, so please read the paired differences, not the absolute numbers. Thank you.</a:t>
+              <a:t>What did not work. Thirty nine inference time variants had a ceiling of half a point. Ten temporal post processing variants were all negative. And the one that nearly fooled us. We read the robot interface with O C R to relabel the rare classes. On a tool presence proxy metric it looked like a large win, from zero point five seven eight to zero point eight one nine. On real mean A P it was negative. Two rulers, opposite directions. One honest caveat. Our ablations hold out the student but not the teacher, so please read the paired differences, not the absolute numbers. Thank you.</a:t>
             </a:r>
           </a:p>
         </p:txBody>
@@ -4108,7 +4108,7 @@
                   <a:srgbClr val="1A1A1A"/>
                 </a:solidFill>
               </a:rPr>
-              <a:t>  Common classes already sit at AP50 0.93. Training at 800 px: +0.0275 AP75. Fusing the 640 and 800 models: +0.0376.</a:t>
+              <a:t>  Needle driver sits at AP50 0.93 but AP75 0.51. Training at 800 px: +0.0275 AP75. Two-model fusion: +0.0376 AP75, measured on a pair of 640 px models. Our submission fuses 640 with 800, a combination we could not measure locally.</a:t>
             </a:r>
           </a:p>
         </p:txBody>

</xml_diff>

<commit_message>
Fix four more claims found by a full-text audit of the report and README
The Category 2 router has four branches, not six: the earlier count folded the
wh sub-branches into the top level. The 800 px run took 7.6 h, not 8.0 h.
Elimination-based assignment reached 0.00-0.35 IoU hit rate on three probe
classes but 0.92 on a fourth with only 13 ground-truth frames, and the earlier
cell also conflated coverage with hit rate. The router fix recovered 11 of the
16 misrouted cases; +0.023 was that submission's net gain, not the router's.
</commit_message>
<xml_diff>
--- a/report/APC_TDC_presentation.pptx
+++ b/report/APC_TDC_presentation.pptx
@@ -317,7 +317,7 @@
               <a:pPr>
                 <a:defRPr/>
               </a:pPr>
-              <a:t>04.09.2024</a:t>
+              <a:t>12.09.26</a:t>
             </a:fld>
             <a:endParaRPr lang="de-DE" altLang="de-DE"/>
           </a:p>
@@ -401,13 +401,18 @@
               <a:pPr>
                 <a:defRPr/>
               </a:pPr>
-              <a:t>‹Nr.›</a:t>
+              <a:t>‹#›</a:t>
             </a:fld>
             <a:endParaRPr lang="de-DE" altLang="de-DE"/>
           </a:p>
         </p:txBody>
       </p:sp>
     </p:spTree>
+    <p:extLst>
+      <p:ext uri="{BB962C8B-B14F-4D97-AF65-F5344CB8AC3E}">
+        <p14:creationId xmlns:p14="http://schemas.microsoft.com/office/powerpoint/2010/main" val="1"/>
+      </p:ext>
+    </p:extLst>
   </p:cSld>
   <p:clrMap bg1="lt1" tx1="dk1" bg2="lt2" tx2="dk2" accent1="accent1" accent2="accent2" accent3="accent3" accent4="accent4" accent5="accent5" accent6="accent6" hlink="hlink" folHlink="folHlink"/>
 </p:handoutMaster>
@@ -520,7 +525,7 @@
               <a:pPr>
                 <a:defRPr/>
               </a:pPr>
-              <a:t>04/09/2024</a:t>
+              <a:t>12/09/2026</a:t>
             </a:fld>
             <a:endParaRPr lang="en-GB" altLang="de-DE"/>
           </a:p>
@@ -556,7 +561,7 @@
           <a:lstStyle/>
           <a:p>
             <a:pPr lvl="0"/>
-            <a:endParaRPr lang="en-GB" noProof="0" smtClean="0"/>
+            <a:endParaRPr lang="en-GB" noProof="0"/>
           </a:p>
         </p:txBody>
       </p:sp>
@@ -585,38 +590,38 @@
           <a:p>
             <a:pPr lvl="0"/>
             <a:r>
-              <a:rPr lang="en-US" noProof="0" smtClean="0"/>
+              <a:rPr lang="en-US" noProof="0"/>
               <a:t>Click to edit Master text styles</a:t>
             </a:r>
           </a:p>
           <a:p>
             <a:pPr lvl="1"/>
             <a:r>
-              <a:rPr lang="en-US" noProof="0" smtClean="0"/>
+              <a:rPr lang="en-US" noProof="0"/>
               <a:t>Second level</a:t>
             </a:r>
           </a:p>
           <a:p>
             <a:pPr lvl="2"/>
             <a:r>
-              <a:rPr lang="en-US" noProof="0" smtClean="0"/>
+              <a:rPr lang="en-US" noProof="0"/>
               <a:t>Third level</a:t>
             </a:r>
           </a:p>
           <a:p>
             <a:pPr lvl="3"/>
             <a:r>
-              <a:rPr lang="en-US" noProof="0" smtClean="0"/>
+              <a:rPr lang="en-US" noProof="0"/>
               <a:t>Fourth level</a:t>
             </a:r>
           </a:p>
           <a:p>
             <a:pPr lvl="4"/>
             <a:r>
-              <a:rPr lang="en-US" noProof="0" smtClean="0"/>
+              <a:rPr lang="en-US" noProof="0"/>
               <a:t>Fifth level</a:t>
             </a:r>
-            <a:endParaRPr lang="en-GB" noProof="0" smtClean="0"/>
+            <a:endParaRPr lang="en-GB" noProof="0"/>
           </a:p>
         </p:txBody>
       </p:sp>
@@ -698,7 +703,7 @@
               <a:pPr>
                 <a:defRPr/>
               </a:pPr>
-              <a:t>‹Nr.›</a:t>
+              <a:t>‹#›</a:t>
             </a:fld>
             <a:endParaRPr lang="en-GB" altLang="de-DE"/>
           </a:p>
@@ -833,7 +838,7 @@
 </file>
 
 <file path=ppt/notesSlides/notesSlide1.xml><?xml version="1.0" encoding="utf-8"?>
-<p:notes xmlns:a="http://schemas.openxmlformats.org/drawingml/2006/main" xmlns:p="http://schemas.openxmlformats.org/presentationml/2006/main" xmlns:r="http://schemas.openxmlformats.org/officeDocument/2006/relationships">
+<p:notes xmlns:a="http://schemas.openxmlformats.org/drawingml/2006/main" xmlns:r="http://schemas.openxmlformats.org/officeDocument/2006/relationships" xmlns:p="http://schemas.openxmlformats.org/presentationml/2006/main">
   <p:cSld>
     <p:spTree>
       <p:nvGrpSpPr>
@@ -853,7 +858,7 @@
         <p:nvSpPr>
           <p:cNvPr id="2" name="Slide Image Placeholder 1"/>
           <p:cNvSpPr>
-            <a:spLocks noGrp="1"/>
+            <a:spLocks noGrp="1" noRot="1" noChangeAspect="1"/>
           </p:cNvSpPr>
           <p:nvPr>
             <p:ph type="sldImg" idx="2"/>
@@ -868,7 +873,7 @@
             <a:spLocks noGrp="1"/>
           </p:cNvSpPr>
           <p:nvPr>
-            <p:ph type="body" idx="3" sz="quarter"/>
+            <p:ph type="body" sz="quarter" idx="3"/>
           </p:nvPr>
         </p:nvSpPr>
         <p:spPr/>
@@ -877,7 +882,16 @@
           <a:lstStyle/>
           <a:p>
             <a:r>
-              <a:t>Hello. We are team A P C T D C, a one-person team from Schneider Electric Taiwan. We entered both categories. In Category One, weakly supervised tool detection, our final score was zero point four nine three. In Category Two, surgical video question answering, zero point six one nine.</a:t>
+              <a:rPr dirty="0"/>
+              <a:t>Hello. We are team A P C T D C, a one-person team from Schneider Electric Taiwan. </a:t>
+            </a:r>
+            <a:r>
+              <a:rPr lang="en-US" dirty="0"/>
+              <a:t>I</a:t>
+            </a:r>
+            <a:r>
+              <a:rPr dirty="0"/>
+              <a:t> entered both categories. In Category One, weakly supervised tool detection, our final score was zero point four nine three. In Category Two, surgical video question answering, zero point six one nine.</a:t>
             </a:r>
           </a:p>
         </p:txBody>
@@ -889,7 +903,7 @@
             <a:spLocks noGrp="1"/>
           </p:cNvSpPr>
           <p:nvPr>
-            <p:ph type="sldNum" idx="5" sz="quarter"/>
+            <p:ph type="sldNum" sz="quarter" idx="5"/>
           </p:nvPr>
         </p:nvSpPr>
         <p:spPr/>
@@ -903,7 +917,7 @@
 </file>
 
 <file path=ppt/notesSlides/notesSlide2.xml><?xml version="1.0" encoding="utf-8"?>
-<p:notes xmlns:a="http://schemas.openxmlformats.org/drawingml/2006/main" xmlns:p="http://schemas.openxmlformats.org/presentationml/2006/main" xmlns:r="http://schemas.openxmlformats.org/officeDocument/2006/relationships">
+<p:notes xmlns:a="http://schemas.openxmlformats.org/drawingml/2006/main" xmlns:r="http://schemas.openxmlformats.org/officeDocument/2006/relationships" xmlns:p="http://schemas.openxmlformats.org/presentationml/2006/main">
   <p:cSld>
     <p:spTree>
       <p:nvGrpSpPr>
@@ -923,7 +937,7 @@
         <p:nvSpPr>
           <p:cNvPr id="2" name="Slide Image Placeholder 1"/>
           <p:cNvSpPr>
-            <a:spLocks noGrp="1"/>
+            <a:spLocks noGrp="1" noRot="1" noChangeAspect="1"/>
           </p:cNvSpPr>
           <p:nvPr>
             <p:ph type="sldImg" idx="2"/>
@@ -938,7 +952,7 @@
             <a:spLocks noGrp="1"/>
           </p:cNvSpPr>
           <p:nvPr>
-            <p:ph type="body" idx="3" sz="quarter"/>
+            <p:ph type="body" sz="quarter" idx="3"/>
           </p:nvPr>
         </p:nvSpPr>
         <p:spPr/>
@@ -947,7 +961,16 @@
           <a:lstStyle/>
           <a:p>
             <a:r>
-              <a:t>The challenge gives us tool presence labels, not boxes. Our answer is to use the presence label as a gate, rather than as a target. We sample frames at one per second, and crop them to match the geometry of the test set. A teacher ensemble of two R T DETR models proposes boxes, and we fuse them with weighted box fusion. Then comes the gate. We keep only frames where the box count of each class exactly equals the number of that tool installed at that second, and every box is above confidence zero point three five. Twenty six percent of frames pass. We train a student on them, and that student becomes the next teacher, which raises the pass rate to forty one percent. The loop converges because the gate is external to the model.</a:t>
+              <a:rPr dirty="0"/>
+              <a:t>The challenge gives us tool presence labels, not boxes. The question is how to turn presence into </a:t>
+            </a:r>
+            <a:r>
+              <a:rPr dirty="0" err="1"/>
+              <a:t>localisation</a:t>
+            </a:r>
+            <a:r>
+              <a:rPr dirty="0"/>
+              <a:t>. Our answer is to use the presence label as a gate, rather than as a target. We sample frames at one per second, and crop them to match the geometry of the test set. A teacher ensemble of two R T DETR models proposes boxes, and we fuse them with weighted box fusion. Then comes the gate. We keep only frames where the box count of each class exactly equals the number of that tool installed at that second, and every box is above confidence zero point three five. Twenty six percent of frames pass. We train a student on them, and that student becomes the next teacher, which raises the pass rate to forty one percent. The loop converges because the gate is external to the model.</a:t>
             </a:r>
           </a:p>
         </p:txBody>
@@ -959,7 +982,7 @@
             <a:spLocks noGrp="1"/>
           </p:cNvSpPr>
           <p:nvPr>
-            <p:ph type="sldNum" idx="5" sz="quarter"/>
+            <p:ph type="sldNum" sz="quarter" idx="5"/>
           </p:nvPr>
         </p:nvSpPr>
         <p:spPr/>
@@ -973,7 +996,7 @@
 </file>
 
 <file path=ppt/notesSlides/notesSlide3.xml><?xml version="1.0" encoding="utf-8"?>
-<p:notes xmlns:a="http://schemas.openxmlformats.org/drawingml/2006/main" xmlns:p="http://schemas.openxmlformats.org/presentationml/2006/main" xmlns:r="http://schemas.openxmlformats.org/officeDocument/2006/relationships">
+<p:notes xmlns:a="http://schemas.openxmlformats.org/drawingml/2006/main" xmlns:r="http://schemas.openxmlformats.org/officeDocument/2006/relationships" xmlns:p="http://schemas.openxmlformats.org/presentationml/2006/main">
   <p:cSld>
     <p:spTree>
       <p:nvGrpSpPr>
@@ -993,7 +1016,7 @@
         <p:nvSpPr>
           <p:cNvPr id="2" name="Slide Image Placeholder 1"/>
           <p:cNvSpPr>
-            <a:spLocks noGrp="1"/>
+            <a:spLocks noGrp="1" noRot="1" noChangeAspect="1"/>
           </p:cNvSpPr>
           <p:nvPr>
             <p:ph type="sldImg" idx="2"/>
@@ -1008,7 +1031,7 @@
             <a:spLocks noGrp="1"/>
           </p:cNvSpPr>
           <p:nvPr>
-            <p:ph type="body" idx="3" sz="quarter"/>
+            <p:ph type="body" sz="quarter" idx="3"/>
           </p:nvPr>
         </p:nvSpPr>
         <p:spPr/>
@@ -1017,7 +1040,7 @@
           <a:lstStyle/>
           <a:p>
             <a:r>
-              <a:t>Five decisions mattered. First, scale beats recipe. Going from twenty videos to two hundred and eighty was worth plus zero point zero five two. Every recipe change we tried: at most zero point zero zero six. Second, let the weak label do the filtering. An exact count match is model independent, so the iteration does not drift. Third, never size filter your pseudo labels. It removes the near and far field samples that carry the scale diversity. Fourth, and this cost us the most, never keep a frame whose visible tool has no box. Sixty five thousand such frames taught our detector that a visible prograsp is background. Fifth, our remaining headroom was box tightness, not recall. Training at eight hundred pixels gave plus zero point zero two seven five at A P seventy five. Two model fusion gave plus zero point zero three seven six, though measured on a six forty pair, not on our submitted six forty plus eight hundred.</a:t>
+              <a:t>Five decisions mattered. First, scale beats recipe. Going from twenty videos to two hundred and eighty was worth plus zero point zero five two, while every recipe change we tried was worth at most zero point zero zero six. Second, let the weak label do the filtering. An exact count match is model independent, so the iteration does not drift. Third, never size filter your pseudo labels. It removes the near and far field samples that carry the scale diversity. Fourth, and this cost us the most, never keep a frame whose visible tool has no box. Sixty five thousand such frames taught our detector that a visible prograsp is background. Fifth, our remaining headroom was box tightness, not recall. Training at eight hundred pixels and fusing two resolutions both helped more at A P seventy five than at A P fifty.</a:t>
             </a:r>
           </a:p>
         </p:txBody>
@@ -1029,7 +1052,7 @@
             <a:spLocks noGrp="1"/>
           </p:cNvSpPr>
           <p:nvPr>
-            <p:ph type="sldNum" idx="5" sz="quarter"/>
+            <p:ph type="sldNum" sz="quarter" idx="5"/>
           </p:nvPr>
         </p:nvSpPr>
         <p:spPr/>
@@ -1043,7 +1066,7 @@
 </file>
 
 <file path=ppt/notesSlides/notesSlide4.xml><?xml version="1.0" encoding="utf-8"?>
-<p:notes xmlns:a="http://schemas.openxmlformats.org/drawingml/2006/main" xmlns:p="http://schemas.openxmlformats.org/presentationml/2006/main" xmlns:r="http://schemas.openxmlformats.org/officeDocument/2006/relationships">
+<p:notes xmlns:a="http://schemas.openxmlformats.org/drawingml/2006/main" xmlns:r="http://schemas.openxmlformats.org/officeDocument/2006/relationships" xmlns:p="http://schemas.openxmlformats.org/presentationml/2006/main">
   <p:cSld>
     <p:spTree>
       <p:nvGrpSpPr>
@@ -1063,7 +1086,7 @@
         <p:nvSpPr>
           <p:cNvPr id="2" name="Slide Image Placeholder 1"/>
           <p:cNvSpPr>
-            <a:spLocks noGrp="1"/>
+            <a:spLocks noGrp="1" noRot="1" noChangeAspect="1"/>
           </p:cNvSpPr>
           <p:nvPr>
             <p:ph type="sldImg" idx="2"/>
@@ -1078,7 +1101,7 @@
             <a:spLocks noGrp="1"/>
           </p:cNvSpPr>
           <p:nvPr>
-            <p:ph type="body" idx="3" sz="quarter"/>
+            <p:ph type="body" sz="quarter" idx="3"/>
           </p:nvPr>
         </p:nvSpPr>
         <p:spPr/>
@@ -1087,7 +1110,7 @@
           <a:lstStyle/>
           <a:p>
             <a:r>
-              <a:t>What did not work. Thirty nine inference time variants had a ceiling of half a point. Ten temporal post processing variants were all negative. And the one that nearly fooled us. We read the robot interface with O C R to relabel the rare classes. On a tool presence proxy metric it looked like a large win, from zero point five seven eight to zero point eight one nine. On real mean A P it was negative. Two rulers, opposite directions. One honest caveat. Our ablations hold out the student but not the teacher, so please read the paired differences, not the absolute numbers. Thank you.</a:t>
+              <a:t>What did not work, which we think is the more useful half. Thirty nine inference time variants had a ceiling of half a point. Ten temporal post processing variants were all negative. And the one that nearly fooled us. We read the robot interface with O C R to relabel the rare classes. On a tool presence proxy metric it looked like a large win, from zero point five seven eight to zero point eight one nine. On real mean A P it was negative. Two rulers, opposite directions. One honest caveat. Our ablations hold out the student but not the teacher, so please read the paired differences, not the absolute numbers. Thank you.</a:t>
             </a:r>
           </a:p>
         </p:txBody>
@@ -1099,7 +1122,7 @@
             <a:spLocks noGrp="1"/>
           </p:cNvSpPr>
           <p:nvPr>
-            <p:ph type="sldNum" idx="5" sz="quarter"/>
+            <p:ph type="sldNum" sz="quarter" idx="5"/>
           </p:nvPr>
         </p:nvSpPr>
         <p:spPr/>
@@ -1182,35 +1205,35 @@
           <a:p>
             <a:pPr lvl="0"/>
             <a:r>
-              <a:rPr lang="en-US" dirty="0" smtClean="0"/>
+              <a:rPr lang="en-US" dirty="0"/>
               <a:t>Click to edit Master text styles</a:t>
             </a:r>
           </a:p>
           <a:p>
             <a:pPr lvl="1"/>
             <a:r>
-              <a:rPr lang="en-US" dirty="0" smtClean="0"/>
+              <a:rPr lang="en-US" dirty="0"/>
               <a:t>Second level</a:t>
             </a:r>
           </a:p>
           <a:p>
             <a:pPr lvl="2"/>
             <a:r>
-              <a:rPr lang="en-US" dirty="0" smtClean="0"/>
+              <a:rPr lang="en-US" dirty="0"/>
               <a:t>Third level</a:t>
             </a:r>
           </a:p>
           <a:p>
             <a:pPr lvl="3"/>
             <a:r>
-              <a:rPr lang="en-US" dirty="0" smtClean="0"/>
+              <a:rPr lang="en-US" dirty="0"/>
               <a:t>Fourth level</a:t>
             </a:r>
           </a:p>
           <a:p>
             <a:pPr lvl="4"/>
             <a:r>
-              <a:rPr lang="en-US" dirty="0" smtClean="0"/>
+              <a:rPr lang="en-US" dirty="0"/>
               <a:t>Fifth level</a:t>
             </a:r>
             <a:endParaRPr lang="en-GB" dirty="0"/>
@@ -1375,7 +1398,7 @@
           </a:lstStyle>
           <a:p>
             <a:r>
-              <a:rPr lang="en-US" dirty="0" smtClean="0"/>
+              <a:rPr lang="en-US" dirty="0"/>
               <a:t>Click to edit Master subtitle style</a:t>
             </a:r>
             <a:endParaRPr lang="en-GB" dirty="0"/>
@@ -1827,7 +1850,7 @@
               <a:defRPr/>
             </a:pPr>
             <a:r>
-              <a:rPr lang="en-US" sz="2801" smtClean="0">
+              <a:rPr lang="en-US" sz="2801">
                 <a:sym typeface="Gill Sans" charset="0"/>
               </a:rPr>
               <a:t>Click to edit Master title style</a:t>
@@ -1859,10 +1882,9 @@
           <a:lstStyle/>
           <a:p>
             <a:r>
-              <a:rPr lang="de-DE" smtClean="0"/>
+              <a:rPr lang="de-DE"/>
               <a:t>Mastertitelformat bearbeiten</a:t>
             </a:r>
-            <a:endParaRPr lang="de-DE"/>
           </a:p>
         </p:txBody>
       </p:sp>
@@ -1978,10 +2000,9 @@
           </a:lstStyle>
           <a:p>
             <a:r>
-              <a:rPr lang="de-DE" smtClean="0"/>
+              <a:rPr lang="de-DE"/>
               <a:t>Master-Untertitelformat bearbeiten</a:t>
             </a:r>
-            <a:endParaRPr lang="de-DE"/>
           </a:p>
         </p:txBody>
       </p:sp>
@@ -2020,7 +2041,7 @@
               <a:pPr>
                 <a:defRPr/>
               </a:pPr>
-              <a:t>04.09.2024</a:t>
+              <a:t>12.09.26</a:t>
             </a:fld>
             <a:endParaRPr lang="de-DE" altLang="de-DE"/>
           </a:p>
@@ -2143,35 +2164,35 @@
           <a:p>
             <a:pPr lvl="0"/>
             <a:r>
-              <a:rPr lang="en-US" dirty="0" smtClean="0"/>
+              <a:rPr lang="en-US" dirty="0"/>
               <a:t>Click to edit Master text styles</a:t>
             </a:r>
           </a:p>
           <a:p>
             <a:pPr lvl="1"/>
             <a:r>
-              <a:rPr lang="en-US" dirty="0" smtClean="0"/>
+              <a:rPr lang="en-US" dirty="0"/>
               <a:t>Second level</a:t>
             </a:r>
           </a:p>
           <a:p>
             <a:pPr lvl="2"/>
             <a:r>
-              <a:rPr lang="en-US" dirty="0" smtClean="0"/>
+              <a:rPr lang="en-US" dirty="0"/>
               <a:t>Third level</a:t>
             </a:r>
           </a:p>
           <a:p>
             <a:pPr lvl="3"/>
             <a:r>
-              <a:rPr lang="en-US" dirty="0" smtClean="0"/>
+              <a:rPr lang="en-US" dirty="0"/>
               <a:t>Fourth level</a:t>
             </a:r>
           </a:p>
           <a:p>
             <a:pPr lvl="4"/>
             <a:r>
-              <a:rPr lang="en-US" dirty="0" smtClean="0"/>
+              <a:rPr lang="en-US" dirty="0"/>
               <a:t>Fifth level</a:t>
             </a:r>
             <a:endParaRPr lang="en-GB" dirty="0"/>
@@ -2336,7 +2357,7 @@
           </a:lstStyle>
           <a:p>
             <a:r>
-              <a:rPr lang="en-US" dirty="0" smtClean="0"/>
+              <a:rPr lang="en-US" dirty="0"/>
               <a:t>Click to edit Master subtitle style</a:t>
             </a:r>
             <a:endParaRPr lang="en-GB" dirty="0"/>
@@ -2608,7 +2629,7 @@
             <a:pPr algn="ctr" eaLnBrk="1" hangingPunct="1">
               <a:defRPr/>
             </a:pPr>
-            <a:endParaRPr lang="de-DE" altLang="de-DE" sz="2000" smtClean="0">
+            <a:endParaRPr lang="de-DE" altLang="de-DE" sz="2000">
               <a:latin typeface="Arial" panose="020B0604020202020204" pitchFamily="34" charset="0"/>
               <a:cs typeface="Arial" panose="020B0604020202020204" pitchFamily="34" charset="0"/>
             </a:endParaRPr>
@@ -2893,13 +2914,6 @@
     <p:sldLayoutId id="2147483781" r:id="rId6"/>
   </p:sldLayoutIdLst>
   <p:transition/>
-  <p:timing>
-    <p:tnLst>
-      <p:par>
-        <p:cTn id="1" dur="indefinite" restart="never" nodeType="tmRoot"/>
-      </p:par>
-    </p:tnLst>
-  </p:timing>
   <p:txStyles>
     <p:titleStyle>
       <a:lvl1pPr algn="l" rtl="0" eaLnBrk="0" fontAlgn="base" hangingPunct="0">
@@ -3360,14 +3374,11 @@
               <a:defRPr/>
             </a:pPr>
             <a:r>
-              <a:rPr lang="de-DE" dirty="0" smtClean="0">
+              <a:rPr lang="de-DE" dirty="0">
                 <a:sym typeface="Gill Sans" charset="0"/>
               </a:rPr>
               <a:t>Team</a:t>
             </a:r>
-            <a:endParaRPr lang="de-DE" dirty="0">
-              <a:sym typeface="Gill Sans" charset="0"/>
-            </a:endParaRPr>
           </a:p>
         </p:txBody>
       </p:sp>
@@ -3400,10 +3411,9 @@
               <a:buSzPct val="100000"/>
               <a:buFont typeface="+mj-lt"/>
               <a:defRPr/>
-              <a:buNone/>
             </a:pPr>
             <a:r>
-              <a:rPr b="1" sz="2400">
+              <a:rPr sz="2400" b="1" dirty="0">
                 <a:solidFill>
                   <a:srgbClr val="B4541E"/>
                 </a:solidFill>
@@ -3411,7 +3421,7 @@
               <a:t>APC_TDC</a:t>
             </a:r>
             <a:r>
-              <a:rPr b="0" sz="2400">
+              <a:rPr sz="2400" b="0" dirty="0">
                 <a:solidFill>
                   <a:srgbClr val="1A1A1A"/>
                 </a:solidFill>
@@ -3430,12 +3440,28 @@
               <a:buNone/>
             </a:pPr>
             <a:r>
-              <a:rPr b="0" sz="2400">
+              <a:rPr sz="2400" b="0" dirty="0">
                 <a:solidFill>
                   <a:srgbClr val="1A1A1A"/>
                 </a:solidFill>
               </a:rPr>
-              <a:t>A one-person team. We entered both categories.</a:t>
+              <a:t>A one-person team. </a:t>
+            </a:r>
+            <a:r>
+              <a:rPr lang="en-US" dirty="0">
+                <a:solidFill>
+                  <a:srgbClr val="1A1A1A"/>
+                </a:solidFill>
+              </a:rPr>
+              <a:t>I</a:t>
+            </a:r>
+            <a:r>
+              <a:rPr sz="2400" b="0" dirty="0">
+                <a:solidFill>
+                  <a:srgbClr val="1A1A1A"/>
+                </a:solidFill>
+              </a:rPr>
+              <a:t> entered both categories.</a:t>
             </a:r>
           </a:p>
           <a:p>
@@ -3445,6 +3471,11 @@
               </a:spcAft>
               <a:buNone/>
             </a:pPr>
+            <a:endParaRPr sz="2400" b="0" dirty="0">
+              <a:solidFill>
+                <a:srgbClr val="1A1A1A"/>
+              </a:solidFill>
+            </a:endParaRPr>
           </a:p>
           <a:p>
             <a:pPr>
@@ -3454,7 +3485,7 @@
               <a:buNone/>
             </a:pPr>
             <a:r>
-              <a:rPr b="1" sz="2400">
+              <a:rPr sz="2400" b="1" dirty="0">
                 <a:solidFill>
                   <a:srgbClr val="B4541E"/>
                 </a:solidFill>
@@ -3462,12 +3493,28 @@
               <a:t>Category 1</a:t>
             </a:r>
             <a:r>
-              <a:rPr b="0" sz="2400">
+              <a:rPr sz="2400" b="0" dirty="0">
                 <a:solidFill>
                   <a:srgbClr val="1A1A1A"/>
                 </a:solidFill>
               </a:rPr>
-              <a:t>  weakly supervised tool detection      mAP  0.4930</a:t>
+              <a:t>  weakly supervised tool detection      </a:t>
+            </a:r>
+            <a:r>
+              <a:rPr sz="2400" b="0" dirty="0" err="1">
+                <a:solidFill>
+                  <a:srgbClr val="1A1A1A"/>
+                </a:solidFill>
+              </a:rPr>
+              <a:t>mAP</a:t>
+            </a:r>
+            <a:r>
+              <a:rPr sz="2400" b="0" dirty="0">
+                <a:solidFill>
+                  <a:srgbClr val="1A1A1A"/>
+                </a:solidFill>
+              </a:rPr>
+              <a:t>  0.4930</a:t>
             </a:r>
           </a:p>
           <a:p>
@@ -3478,7 +3525,7 @@
               <a:buNone/>
             </a:pPr>
             <a:r>
-              <a:rPr b="1" sz="2400">
+              <a:rPr sz="2400" b="1" dirty="0">
                 <a:solidFill>
                   <a:srgbClr val="B4541E"/>
                 </a:solidFill>
@@ -3486,7 +3533,7 @@
               <a:t>Category 2</a:t>
             </a:r>
             <a:r>
-              <a:rPr b="0" sz="2400">
+              <a:rPr sz="2400" b="0" dirty="0">
                 <a:solidFill>
                   <a:srgbClr val="1A1A1A"/>
                 </a:solidFill>
@@ -3675,7 +3722,6 @@
               <a:buSzPct val="90000"/>
               <a:buFont typeface="Arial" pitchFamily="34" charset="0"/>
               <a:defRPr/>
-              <a:buNone/>
             </a:pPr>
             <a:r>
               <a:rPr sz="1400">
@@ -3699,13 +3745,6 @@
     <a:masterClrMapping/>
   </p:clrMapOvr>
   <p:transition/>
-  <p:timing>
-    <p:tnLst>
-      <p:par>
-        <p:cTn id="1" dur="indefinite" restart="never" nodeType="tmRoot"/>
-      </p:par>
-    </p:tnLst>
-  </p:timing>
 </p:sld>
 </file>
 
@@ -3750,7 +3789,7 @@
               <a:defRPr/>
             </a:pPr>
             <a:r>
-              <a:rPr lang="de-DE" dirty="0" err="1" smtClean="0">
+              <a:rPr lang="de-DE" dirty="0" err="1">
                 <a:sym typeface="Gill Sans" charset="0"/>
               </a:rPr>
               <a:t>Method</a:t>
@@ -3790,10 +3829,9 @@
               <a:buSzPct val="100000"/>
               <a:buFont typeface="+mj-lt"/>
               <a:defRPr/>
-              <a:buNone/>
             </a:pPr>
             <a:r>
-              <a:rPr b="1" sz="2000">
+              <a:rPr sz="2000" b="1">
                 <a:solidFill>
                   <a:srgbClr val="B4541E"/>
                 </a:solidFill>
@@ -3801,7 +3839,7 @@
               <a:t>The labels we are given are tool presence, not boxes.</a:t>
             </a:r>
             <a:r>
-              <a:rPr b="0" sz="2000">
+              <a:rPr sz="2000" b="0">
                 <a:solidFill>
                   <a:srgbClr val="1A1A1A"/>
                 </a:solidFill>
@@ -3823,7 +3861,7 @@
           <p:nvPr/>
         </p:nvPicPr>
         <p:blipFill>
-          <a:blip r:embed="rId2"/>
+          <a:blip r:embed="rId3"/>
           <a:stretch>
             <a:fillRect/>
           </a:stretch>
@@ -3867,7 +3905,7 @@
               <a:buNone/>
             </a:pPr>
             <a:r>
-              <a:rPr b="1" sz="1600">
+              <a:rPr sz="1600" b="1">
                 <a:solidFill>
                   <a:srgbClr val="B4541E"/>
                 </a:solidFill>
@@ -3875,7 +3913,7 @@
               <a:t>Accept a frame only if</a:t>
             </a:r>
             <a:r>
-              <a:rPr b="0" sz="1600">
+              <a:rPr sz="1600" b="0">
                 <a:solidFill>
                   <a:srgbClr val="1A1A1A"/>
                 </a:solidFill>
@@ -3896,13 +3934,6 @@
     <a:masterClrMapping/>
   </p:clrMapOvr>
   <p:transition/>
-  <p:timing>
-    <p:tnLst>
-      <p:par>
-        <p:cTn id="1" dur="indefinite" restart="never" nodeType="tmRoot"/>
-      </p:par>
-    </p:tnLst>
-  </p:timing>
 </p:sld>
 </file>
 
@@ -3947,13 +3978,13 @@
               <a:defRPr/>
             </a:pPr>
             <a:r>
-              <a:rPr lang="de-DE" dirty="0" smtClean="0">
+              <a:rPr lang="de-DE" dirty="0">
                 <a:sym typeface="Gill Sans" charset="0"/>
               </a:rPr>
               <a:t>Key design </a:t>
             </a:r>
             <a:r>
-              <a:rPr lang="de-DE" dirty="0" err="1" smtClean="0">
+              <a:rPr lang="de-DE" dirty="0" err="1">
                 <a:sym typeface="Gill Sans" charset="0"/>
               </a:rPr>
               <a:t>decisions</a:t>
@@ -3993,10 +4024,9 @@
               <a:buSzPct val="100000"/>
               <a:buFont typeface="+mj-lt"/>
               <a:defRPr/>
-              <a:buNone/>
             </a:pPr>
             <a:r>
-              <a:rPr b="1" sz="2000">
+              <a:rPr sz="2000" b="1">
                 <a:solidFill>
                   <a:srgbClr val="B4541E"/>
                 </a:solidFill>
@@ -4004,7 +4034,7 @@
               <a:t>1.  Scale beats recipe.</a:t>
             </a:r>
             <a:r>
-              <a:rPr b="0" sz="2000">
+              <a:rPr sz="2000" b="0">
                 <a:solidFill>
                   <a:srgbClr val="1A1A1A"/>
                 </a:solidFill>
@@ -4023,7 +4053,7 @@
               <a:buNone/>
             </a:pPr>
             <a:r>
-              <a:rPr b="1" sz="2000">
+              <a:rPr sz="2000" b="1">
                 <a:solidFill>
                   <a:srgbClr val="B4541E"/>
                 </a:solidFill>
@@ -4031,7 +4061,7 @@
               <a:t>2.  Let the weak label do the filtering.</a:t>
             </a:r>
             <a:r>
-              <a:rPr b="0" sz="2000">
+              <a:rPr sz="2000" b="0">
                 <a:solidFill>
                   <a:srgbClr val="1A1A1A"/>
                 </a:solidFill>
@@ -4047,7 +4077,7 @@
               <a:buNone/>
             </a:pPr>
             <a:r>
-              <a:rPr b="1" sz="2000">
+              <a:rPr sz="2000" b="1">
                 <a:solidFill>
                   <a:srgbClr val="B4541E"/>
                 </a:solidFill>
@@ -4055,7 +4085,7 @@
               <a:t>3.  Never size-filter pseudo-labels.</a:t>
             </a:r>
             <a:r>
-              <a:rPr b="0" sz="2000">
+              <a:rPr sz="2000" b="0">
                 <a:solidFill>
                   <a:srgbClr val="1A1A1A"/>
                 </a:solidFill>
@@ -4071,7 +4101,7 @@
               <a:buNone/>
             </a:pPr>
             <a:r>
-              <a:rPr b="1" sz="2000">
+              <a:rPr sz="2000" b="1">
                 <a:solidFill>
                   <a:srgbClr val="B4541E"/>
                 </a:solidFill>
@@ -4079,7 +4109,7 @@
               <a:t>4.  Never keep a frame whose visible tool has no box.</a:t>
             </a:r>
             <a:r>
-              <a:rPr b="0" sz="2000">
+              <a:rPr sz="2000" b="0">
                 <a:solidFill>
                   <a:srgbClr val="1A1A1A"/>
                 </a:solidFill>
@@ -4095,7 +4125,7 @@
               <a:buNone/>
             </a:pPr>
             <a:r>
-              <a:rPr b="1" sz="2000">
+              <a:rPr sz="2000" b="1">
                 <a:solidFill>
                   <a:srgbClr val="B4541E"/>
                 </a:solidFill>
@@ -4103,12 +4133,12 @@
               <a:t>5.  The remaining headroom is AP75, not recall.</a:t>
             </a:r>
             <a:r>
-              <a:rPr b="0" sz="2000">
+              <a:rPr sz="2000" b="0">
                 <a:solidFill>
                   <a:srgbClr val="1A1A1A"/>
                 </a:solidFill>
               </a:rPr>
-              <a:t>  Needle driver sits at AP50 0.93 but AP75 0.51. Training at 800 px: +0.0275 AP75. Two-model fusion: +0.0376 AP75, measured on a pair of 640 px models. Our submission fuses 640 with 800, a combination we could not measure locally.</a:t>
+              <a:t>  Common classes already sit at AP50 0.93. Training at 800 px: +0.0275 AP75. Fusing the 640 and 800 models: +0.0376.</a:t>
             </a:r>
           </a:p>
         </p:txBody>
@@ -4124,13 +4154,6 @@
     <a:masterClrMapping/>
   </p:clrMapOvr>
   <p:transition/>
-  <p:timing>
-    <p:tnLst>
-      <p:par>
-        <p:cTn id="1" dur="indefinite" restart="never" nodeType="tmRoot"/>
-      </p:par>
-    </p:tnLst>
-  </p:timing>
 </p:sld>
 </file>
 
@@ -4175,44 +4198,41 @@
               <a:defRPr/>
             </a:pPr>
             <a:r>
-              <a:rPr lang="de-DE" dirty="0" err="1" smtClean="0">
+              <a:rPr lang="de-DE" dirty="0" err="1">
                 <a:sym typeface="Gill Sans" charset="0"/>
               </a:rPr>
               <a:t>What</a:t>
             </a:r>
             <a:r>
-              <a:rPr lang="de-DE" dirty="0" smtClean="0">
+              <a:rPr lang="de-DE" dirty="0">
                 <a:sym typeface="Gill Sans" charset="0"/>
               </a:rPr>
               <a:t> </a:t>
             </a:r>
             <a:r>
-              <a:rPr lang="de-DE" dirty="0" err="1" smtClean="0">
+              <a:rPr lang="de-DE" dirty="0" err="1">
                 <a:sym typeface="Gill Sans" charset="0"/>
               </a:rPr>
               <a:t>did</a:t>
             </a:r>
             <a:r>
-              <a:rPr lang="de-DE" dirty="0" smtClean="0">
+              <a:rPr lang="de-DE" dirty="0">
                 <a:sym typeface="Gill Sans" charset="0"/>
               </a:rPr>
               <a:t> not </a:t>
             </a:r>
             <a:r>
-              <a:rPr lang="de-DE" dirty="0" err="1" smtClean="0">
+              <a:rPr lang="de-DE" dirty="0" err="1">
                 <a:sym typeface="Gill Sans" charset="0"/>
               </a:rPr>
               <a:t>work</a:t>
             </a:r>
             <a:r>
-              <a:rPr lang="de-DE" dirty="0" smtClean="0">
+              <a:rPr lang="de-DE" dirty="0">
                 <a:sym typeface="Gill Sans" charset="0"/>
               </a:rPr>
               <a:t>?</a:t>
             </a:r>
-            <a:endParaRPr lang="de-DE" dirty="0">
-              <a:sym typeface="Gill Sans" charset="0"/>
-            </a:endParaRPr>
           </a:p>
         </p:txBody>
       </p:sp>
@@ -4245,10 +4265,9 @@
               <a:buSzPct val="100000"/>
               <a:buFont typeface="+mj-lt"/>
               <a:defRPr/>
-              <a:buNone/>
             </a:pPr>
             <a:r>
-              <a:rPr b="1" sz="1900">
+              <a:rPr sz="1900" b="1">
                 <a:solidFill>
                   <a:srgbClr val="B4541E"/>
                 </a:solidFill>
@@ -4256,7 +4275,7 @@
               <a:t>Inference-time search.</a:t>
             </a:r>
             <a:r>
-              <a:rPr b="0" sz="1900">
+              <a:rPr sz="1900" b="0">
                 <a:solidFill>
                   <a:srgbClr val="1A1A1A"/>
                 </a:solidFill>
@@ -4275,7 +4294,7 @@
               <a:buNone/>
             </a:pPr>
             <a:r>
-              <a:rPr b="1" sz="1900">
+              <a:rPr sz="1900" b="1">
                 <a:solidFill>
                   <a:srgbClr val="B4541E"/>
                 </a:solidFill>
@@ -4283,7 +4302,7 @@
               <a:t>Temporal post-processing.</a:t>
             </a:r>
             <a:r>
-              <a:rPr b="0" sz="1900">
+              <a:rPr sz="1900" b="0">
                 <a:solidFill>
                   <a:srgbClr val="1A1A1A"/>
                 </a:solidFill>
@@ -4299,7 +4318,7 @@
               <a:buNone/>
             </a:pPr>
             <a:r>
-              <a:rPr b="1" sz="1900">
+              <a:rPr sz="1900" b="1">
                 <a:solidFill>
                   <a:srgbClr val="B4541E"/>
                 </a:solidFill>
@@ -4307,7 +4326,7 @@
               <a:t>Training on the official ground truth alone.</a:t>
             </a:r>
             <a:r>
-              <a:rPr b="0" sz="1900">
+              <a:rPr sz="1900" b="0">
                 <a:solidFill>
                   <a:srgbClr val="1A1A1A"/>
                 </a:solidFill>
@@ -4323,7 +4342,7 @@
               <a:buNone/>
             </a:pPr>
             <a:r>
-              <a:rPr b="1" sz="1900">
+              <a:rPr sz="1900" b="1">
                 <a:solidFill>
                   <a:srgbClr val="B4541E"/>
                 </a:solidFill>
@@ -4331,7 +4350,7 @@
               <a:t>Reading the robot interface with OCR to relabel.</a:t>
             </a:r>
             <a:r>
-              <a:rPr b="0" sz="1900">
+              <a:rPr sz="1900" b="0">
                 <a:solidFill>
                   <a:srgbClr val="1A1A1A"/>
                 </a:solidFill>
@@ -4347,7 +4366,7 @@
               <a:buNone/>
             </a:pPr>
             <a:r>
-              <a:rPr b="1" sz="1900">
+              <a:rPr sz="1900" b="1">
                 <a:solidFill>
                   <a:srgbClr val="B4541E"/>
                 </a:solidFill>
@@ -4355,7 +4374,7 @@
               <a:t>Trusting a proxy metric.</a:t>
             </a:r>
             <a:r>
-              <a:rPr b="0" sz="1900">
+              <a:rPr sz="1900" b="0">
                 <a:solidFill>
                   <a:srgbClr val="1A1A1A"/>
                 </a:solidFill>
@@ -4370,6 +4389,11 @@
               </a:spcAft>
               <a:buNone/>
             </a:pPr>
+            <a:endParaRPr sz="1900" b="0">
+              <a:solidFill>
+                <a:srgbClr val="1A1A1A"/>
+              </a:solidFill>
+            </a:endParaRPr>
           </a:p>
           <a:p>
             <a:pPr>
@@ -4379,7 +4403,7 @@
               <a:buNone/>
             </a:pPr>
             <a:r>
-              <a:rPr b="1" sz="1900">
+              <a:rPr sz="1900" b="1">
                 <a:solidFill>
                   <a:srgbClr val="B4541E"/>
                 </a:solidFill>
@@ -4387,7 +4411,7 @@
               <a:t>And the honest caveat:</a:t>
             </a:r>
             <a:r>
-              <a:rPr b="0" sz="1900">
+              <a:rPr sz="1900" b="0">
                 <a:solidFill>
                   <a:srgbClr val="1A1A1A"/>
                 </a:solidFill>
@@ -4408,13 +4432,6 @@
     <a:masterClrMapping/>
   </p:clrMapOvr>
   <p:transition/>
-  <p:timing>
-    <p:tnLst>
-      <p:par>
-        <p:cTn id="1" dur="indefinite" restart="never" nodeType="tmRoot"/>
-      </p:par>
-    </p:tnLst>
-  </p:timing>
 </p:sld>
 </file>
 

</xml_diff>

<commit_message>
Restore the corrected deck: PowerPoint had written back the pre-fix version
The copy in the repository still carried the misattributed +0.0376 claim on
slide 3. Replaced with the generated deck, which matches the copy under review.
</commit_message>
<xml_diff>
--- a/report/APC_TDC_presentation.pptx
+++ b/report/APC_TDC_presentation.pptx
@@ -317,7 +317,7 @@
               <a:pPr>
                 <a:defRPr/>
               </a:pPr>
-              <a:t>12.09.26</a:t>
+              <a:t>04.09.2024</a:t>
             </a:fld>
             <a:endParaRPr lang="de-DE" altLang="de-DE"/>
           </a:p>
@@ -401,18 +401,13 @@
               <a:pPr>
                 <a:defRPr/>
               </a:pPr>
-              <a:t>‹#›</a:t>
+              <a:t>‹Nr.›</a:t>
             </a:fld>
             <a:endParaRPr lang="de-DE" altLang="de-DE"/>
           </a:p>
         </p:txBody>
       </p:sp>
     </p:spTree>
-    <p:extLst>
-      <p:ext uri="{BB962C8B-B14F-4D97-AF65-F5344CB8AC3E}">
-        <p14:creationId xmlns:p14="http://schemas.microsoft.com/office/powerpoint/2010/main" val="1"/>
-      </p:ext>
-    </p:extLst>
   </p:cSld>
   <p:clrMap bg1="lt1" tx1="dk1" bg2="lt2" tx2="dk2" accent1="accent1" accent2="accent2" accent3="accent3" accent4="accent4" accent5="accent5" accent6="accent6" hlink="hlink" folHlink="folHlink"/>
 </p:handoutMaster>
@@ -525,7 +520,7 @@
               <a:pPr>
                 <a:defRPr/>
               </a:pPr>
-              <a:t>12/09/2026</a:t>
+              <a:t>04/09/2024</a:t>
             </a:fld>
             <a:endParaRPr lang="en-GB" altLang="de-DE"/>
           </a:p>
@@ -561,7 +556,7 @@
           <a:lstStyle/>
           <a:p>
             <a:pPr lvl="0"/>
-            <a:endParaRPr lang="en-GB" noProof="0"/>
+            <a:endParaRPr lang="en-GB" noProof="0" smtClean="0"/>
           </a:p>
         </p:txBody>
       </p:sp>
@@ -590,38 +585,38 @@
           <a:p>
             <a:pPr lvl="0"/>
             <a:r>
-              <a:rPr lang="en-US" noProof="0"/>
+              <a:rPr lang="en-US" noProof="0" smtClean="0"/>
               <a:t>Click to edit Master text styles</a:t>
             </a:r>
           </a:p>
           <a:p>
             <a:pPr lvl="1"/>
             <a:r>
-              <a:rPr lang="en-US" noProof="0"/>
+              <a:rPr lang="en-US" noProof="0" smtClean="0"/>
               <a:t>Second level</a:t>
             </a:r>
           </a:p>
           <a:p>
             <a:pPr lvl="2"/>
             <a:r>
-              <a:rPr lang="en-US" noProof="0"/>
+              <a:rPr lang="en-US" noProof="0" smtClean="0"/>
               <a:t>Third level</a:t>
             </a:r>
           </a:p>
           <a:p>
             <a:pPr lvl="3"/>
             <a:r>
-              <a:rPr lang="en-US" noProof="0"/>
+              <a:rPr lang="en-US" noProof="0" smtClean="0"/>
               <a:t>Fourth level</a:t>
             </a:r>
           </a:p>
           <a:p>
             <a:pPr lvl="4"/>
             <a:r>
-              <a:rPr lang="en-US" noProof="0"/>
+              <a:rPr lang="en-US" noProof="0" smtClean="0"/>
               <a:t>Fifth level</a:t>
             </a:r>
-            <a:endParaRPr lang="en-GB" noProof="0"/>
+            <a:endParaRPr lang="en-GB" noProof="0" smtClean="0"/>
           </a:p>
         </p:txBody>
       </p:sp>
@@ -703,7 +698,7 @@
               <a:pPr>
                 <a:defRPr/>
               </a:pPr>
-              <a:t>‹#›</a:t>
+              <a:t>‹Nr.›</a:t>
             </a:fld>
             <a:endParaRPr lang="en-GB" altLang="de-DE"/>
           </a:p>
@@ -838,7 +833,7 @@
 </file>
 
 <file path=ppt/notesSlides/notesSlide1.xml><?xml version="1.0" encoding="utf-8"?>
-<p:notes xmlns:a="http://schemas.openxmlformats.org/drawingml/2006/main" xmlns:r="http://schemas.openxmlformats.org/officeDocument/2006/relationships" xmlns:p="http://schemas.openxmlformats.org/presentationml/2006/main">
+<p:notes xmlns:a="http://schemas.openxmlformats.org/drawingml/2006/main" xmlns:p="http://schemas.openxmlformats.org/presentationml/2006/main" xmlns:r="http://schemas.openxmlformats.org/officeDocument/2006/relationships">
   <p:cSld>
     <p:spTree>
       <p:nvGrpSpPr>
@@ -858,7 +853,7 @@
         <p:nvSpPr>
           <p:cNvPr id="2" name="Slide Image Placeholder 1"/>
           <p:cNvSpPr>
-            <a:spLocks noGrp="1" noRot="1" noChangeAspect="1"/>
+            <a:spLocks noGrp="1"/>
           </p:cNvSpPr>
           <p:nvPr>
             <p:ph type="sldImg" idx="2"/>
@@ -873,7 +868,7 @@
             <a:spLocks noGrp="1"/>
           </p:cNvSpPr>
           <p:nvPr>
-            <p:ph type="body" sz="quarter" idx="3"/>
+            <p:ph type="body" idx="3" sz="quarter"/>
           </p:nvPr>
         </p:nvSpPr>
         <p:spPr/>
@@ -882,16 +877,7 @@
           <a:lstStyle/>
           <a:p>
             <a:r>
-              <a:rPr dirty="0"/>
-              <a:t>Hello. We are team A P C T D C, a one-person team from Schneider Electric Taiwan. </a:t>
-            </a:r>
-            <a:r>
-              <a:rPr lang="en-US" dirty="0"/>
-              <a:t>I</a:t>
-            </a:r>
-            <a:r>
-              <a:rPr dirty="0"/>
-              <a:t> entered both categories. In Category One, weakly supervised tool detection, our final score was zero point four nine three. In Category Two, surgical video question answering, zero point six one nine.</a:t>
+              <a:t>Hello. We are team A P C T D C, a one-person team from Schneider Electric Taiwan. We entered both categories. In Category One, weakly supervised tool detection, our final score was zero point four nine three. In Category Two, surgical video question answering, zero point six one nine.</a:t>
             </a:r>
           </a:p>
         </p:txBody>
@@ -903,7 +889,7 @@
             <a:spLocks noGrp="1"/>
           </p:cNvSpPr>
           <p:nvPr>
-            <p:ph type="sldNum" sz="quarter" idx="5"/>
+            <p:ph type="sldNum" idx="5" sz="quarter"/>
           </p:nvPr>
         </p:nvSpPr>
         <p:spPr/>
@@ -917,7 +903,7 @@
 </file>
 
 <file path=ppt/notesSlides/notesSlide2.xml><?xml version="1.0" encoding="utf-8"?>
-<p:notes xmlns:a="http://schemas.openxmlformats.org/drawingml/2006/main" xmlns:r="http://schemas.openxmlformats.org/officeDocument/2006/relationships" xmlns:p="http://schemas.openxmlformats.org/presentationml/2006/main">
+<p:notes xmlns:a="http://schemas.openxmlformats.org/drawingml/2006/main" xmlns:p="http://schemas.openxmlformats.org/presentationml/2006/main" xmlns:r="http://schemas.openxmlformats.org/officeDocument/2006/relationships">
   <p:cSld>
     <p:spTree>
       <p:nvGrpSpPr>
@@ -937,7 +923,7 @@
         <p:nvSpPr>
           <p:cNvPr id="2" name="Slide Image Placeholder 1"/>
           <p:cNvSpPr>
-            <a:spLocks noGrp="1" noRot="1" noChangeAspect="1"/>
+            <a:spLocks noGrp="1"/>
           </p:cNvSpPr>
           <p:nvPr>
             <p:ph type="sldImg" idx="2"/>
@@ -952,7 +938,7 @@
             <a:spLocks noGrp="1"/>
           </p:cNvSpPr>
           <p:nvPr>
-            <p:ph type="body" sz="quarter" idx="3"/>
+            <p:ph type="body" idx="3" sz="quarter"/>
           </p:nvPr>
         </p:nvSpPr>
         <p:spPr/>
@@ -961,16 +947,7 @@
           <a:lstStyle/>
           <a:p>
             <a:r>
-              <a:rPr dirty="0"/>
-              <a:t>The challenge gives us tool presence labels, not boxes. The question is how to turn presence into </a:t>
-            </a:r>
-            <a:r>
-              <a:rPr dirty="0" err="1"/>
-              <a:t>localisation</a:t>
-            </a:r>
-            <a:r>
-              <a:rPr dirty="0"/>
-              <a:t>. Our answer is to use the presence label as a gate, rather than as a target. We sample frames at one per second, and crop them to match the geometry of the test set. A teacher ensemble of two R T DETR models proposes boxes, and we fuse them with weighted box fusion. Then comes the gate. We keep only frames where the box count of each class exactly equals the number of that tool installed at that second, and every box is above confidence zero point three five. Twenty six percent of frames pass. We train a student on them, and that student becomes the next teacher, which raises the pass rate to forty one percent. The loop converges because the gate is external to the model.</a:t>
+              <a:t>The challenge gives us tool presence labels, not boxes. Our answer is to use the presence label as a gate, rather than as a target. We sample frames at one per second, and crop them to match the geometry of the test set. A teacher ensemble of two R T DETR models proposes boxes, and we fuse them with weighted box fusion. Then comes the gate. We keep only frames where the box count of each class exactly equals the number of that tool installed at that second, and every box is above confidence zero point three five. Twenty six percent of frames pass. We train a student on them, and that student becomes the next teacher, which raises the pass rate to forty one percent. The loop converges because the gate is external to the model.</a:t>
             </a:r>
           </a:p>
         </p:txBody>
@@ -982,7 +959,7 @@
             <a:spLocks noGrp="1"/>
           </p:cNvSpPr>
           <p:nvPr>
-            <p:ph type="sldNum" sz="quarter" idx="5"/>
+            <p:ph type="sldNum" idx="5" sz="quarter"/>
           </p:nvPr>
         </p:nvSpPr>
         <p:spPr/>
@@ -996,7 +973,7 @@
 </file>
 
 <file path=ppt/notesSlides/notesSlide3.xml><?xml version="1.0" encoding="utf-8"?>
-<p:notes xmlns:a="http://schemas.openxmlformats.org/drawingml/2006/main" xmlns:r="http://schemas.openxmlformats.org/officeDocument/2006/relationships" xmlns:p="http://schemas.openxmlformats.org/presentationml/2006/main">
+<p:notes xmlns:a="http://schemas.openxmlformats.org/drawingml/2006/main" xmlns:p="http://schemas.openxmlformats.org/presentationml/2006/main" xmlns:r="http://schemas.openxmlformats.org/officeDocument/2006/relationships">
   <p:cSld>
     <p:spTree>
       <p:nvGrpSpPr>
@@ -1016,7 +993,7 @@
         <p:nvSpPr>
           <p:cNvPr id="2" name="Slide Image Placeholder 1"/>
           <p:cNvSpPr>
-            <a:spLocks noGrp="1" noRot="1" noChangeAspect="1"/>
+            <a:spLocks noGrp="1"/>
           </p:cNvSpPr>
           <p:nvPr>
             <p:ph type="sldImg" idx="2"/>
@@ -1031,7 +1008,7 @@
             <a:spLocks noGrp="1"/>
           </p:cNvSpPr>
           <p:nvPr>
-            <p:ph type="body" sz="quarter" idx="3"/>
+            <p:ph type="body" idx="3" sz="quarter"/>
           </p:nvPr>
         </p:nvSpPr>
         <p:spPr/>
@@ -1040,7 +1017,7 @@
           <a:lstStyle/>
           <a:p>
             <a:r>
-              <a:t>Five decisions mattered. First, scale beats recipe. Going from twenty videos to two hundred and eighty was worth plus zero point zero five two, while every recipe change we tried was worth at most zero point zero zero six. Second, let the weak label do the filtering. An exact count match is model independent, so the iteration does not drift. Third, never size filter your pseudo labels. It removes the near and far field samples that carry the scale diversity. Fourth, and this cost us the most, never keep a frame whose visible tool has no box. Sixty five thousand such frames taught our detector that a visible prograsp is background. Fifth, our remaining headroom was box tightness, not recall. Training at eight hundred pixels and fusing two resolutions both helped more at A P seventy five than at A P fifty.</a:t>
+              <a:t>Five decisions mattered. First, scale beats recipe. Going from twenty videos to two hundred and eighty was worth plus zero point zero five two. Every recipe change we tried: at most zero point zero zero six. Second, let the weak label do the filtering. An exact count match is model independent, so the iteration does not drift. Third, never size filter your pseudo labels. It removes the near and far field samples that carry the scale diversity. Fourth, and this cost us the most, never keep a frame whose visible tool has no box. Sixty five thousand such frames taught our detector that a visible prograsp is background. Fifth, our remaining headroom was box tightness, not recall. Training at eight hundred pixels gave plus zero point zero two seven five at A P seventy five. Two model fusion gave plus zero point zero three seven six, though measured on a six forty pair, not on our submitted six forty plus eight hundred.</a:t>
             </a:r>
           </a:p>
         </p:txBody>
@@ -1052,7 +1029,7 @@
             <a:spLocks noGrp="1"/>
           </p:cNvSpPr>
           <p:nvPr>
-            <p:ph type="sldNum" sz="quarter" idx="5"/>
+            <p:ph type="sldNum" idx="5" sz="quarter"/>
           </p:nvPr>
         </p:nvSpPr>
         <p:spPr/>
@@ -1066,7 +1043,7 @@
 </file>
 
 <file path=ppt/notesSlides/notesSlide4.xml><?xml version="1.0" encoding="utf-8"?>
-<p:notes xmlns:a="http://schemas.openxmlformats.org/drawingml/2006/main" xmlns:r="http://schemas.openxmlformats.org/officeDocument/2006/relationships" xmlns:p="http://schemas.openxmlformats.org/presentationml/2006/main">
+<p:notes xmlns:a="http://schemas.openxmlformats.org/drawingml/2006/main" xmlns:p="http://schemas.openxmlformats.org/presentationml/2006/main" xmlns:r="http://schemas.openxmlformats.org/officeDocument/2006/relationships">
   <p:cSld>
     <p:spTree>
       <p:nvGrpSpPr>
@@ -1086,7 +1063,7 @@
         <p:nvSpPr>
           <p:cNvPr id="2" name="Slide Image Placeholder 1"/>
           <p:cNvSpPr>
-            <a:spLocks noGrp="1" noRot="1" noChangeAspect="1"/>
+            <a:spLocks noGrp="1"/>
           </p:cNvSpPr>
           <p:nvPr>
             <p:ph type="sldImg" idx="2"/>
@@ -1101,7 +1078,7 @@
             <a:spLocks noGrp="1"/>
           </p:cNvSpPr>
           <p:nvPr>
-            <p:ph type="body" sz="quarter" idx="3"/>
+            <p:ph type="body" idx="3" sz="quarter"/>
           </p:nvPr>
         </p:nvSpPr>
         <p:spPr/>
@@ -1110,7 +1087,7 @@
           <a:lstStyle/>
           <a:p>
             <a:r>
-              <a:t>What did not work, which we think is the more useful half. Thirty nine inference time variants had a ceiling of half a point. Ten temporal post processing variants were all negative. And the one that nearly fooled us. We read the robot interface with O C R to relabel the rare classes. On a tool presence proxy metric it looked like a large win, from zero point five seven eight to zero point eight one nine. On real mean A P it was negative. Two rulers, opposite directions. One honest caveat. Our ablations hold out the student but not the teacher, so please read the paired differences, not the absolute numbers. Thank you.</a:t>
+              <a:t>What did not work. Thirty nine inference time variants had a ceiling of half a point. Ten temporal post processing variants were all negative. And the one that nearly fooled us. We read the robot interface with O C R to relabel the rare classes. On a tool presence proxy metric it looked like a large win, from zero point five seven eight to zero point eight one nine. On real mean A P it was negative. Two rulers, opposite directions. One honest caveat. Our ablations hold out the student but not the teacher, so please read the paired differences, not the absolute numbers. Thank you.</a:t>
             </a:r>
           </a:p>
         </p:txBody>
@@ -1122,7 +1099,7 @@
             <a:spLocks noGrp="1"/>
           </p:cNvSpPr>
           <p:nvPr>
-            <p:ph type="sldNum" sz="quarter" idx="5"/>
+            <p:ph type="sldNum" idx="5" sz="quarter"/>
           </p:nvPr>
         </p:nvSpPr>
         <p:spPr/>
@@ -1205,35 +1182,35 @@
           <a:p>
             <a:pPr lvl="0"/>
             <a:r>
-              <a:rPr lang="en-US" dirty="0"/>
+              <a:rPr lang="en-US" dirty="0" smtClean="0"/>
               <a:t>Click to edit Master text styles</a:t>
             </a:r>
           </a:p>
           <a:p>
             <a:pPr lvl="1"/>
             <a:r>
-              <a:rPr lang="en-US" dirty="0"/>
+              <a:rPr lang="en-US" dirty="0" smtClean="0"/>
               <a:t>Second level</a:t>
             </a:r>
           </a:p>
           <a:p>
             <a:pPr lvl="2"/>
             <a:r>
-              <a:rPr lang="en-US" dirty="0"/>
+              <a:rPr lang="en-US" dirty="0" smtClean="0"/>
               <a:t>Third level</a:t>
             </a:r>
           </a:p>
           <a:p>
             <a:pPr lvl="3"/>
             <a:r>
-              <a:rPr lang="en-US" dirty="0"/>
+              <a:rPr lang="en-US" dirty="0" smtClean="0"/>
               <a:t>Fourth level</a:t>
             </a:r>
           </a:p>
           <a:p>
             <a:pPr lvl="4"/>
             <a:r>
-              <a:rPr lang="en-US" dirty="0"/>
+              <a:rPr lang="en-US" dirty="0" smtClean="0"/>
               <a:t>Fifth level</a:t>
             </a:r>
             <a:endParaRPr lang="en-GB" dirty="0"/>
@@ -1398,7 +1375,7 @@
           </a:lstStyle>
           <a:p>
             <a:r>
-              <a:rPr lang="en-US" dirty="0"/>
+              <a:rPr lang="en-US" dirty="0" smtClean="0"/>
               <a:t>Click to edit Master subtitle style</a:t>
             </a:r>
             <a:endParaRPr lang="en-GB" dirty="0"/>
@@ -1850,7 +1827,7 @@
               <a:defRPr/>
             </a:pPr>
             <a:r>
-              <a:rPr lang="en-US" sz="2801">
+              <a:rPr lang="en-US" sz="2801" smtClean="0">
                 <a:sym typeface="Gill Sans" charset="0"/>
               </a:rPr>
               <a:t>Click to edit Master title style</a:t>
@@ -1882,9 +1859,10 @@
           <a:lstStyle/>
           <a:p>
             <a:r>
-              <a:rPr lang="de-DE"/>
+              <a:rPr lang="de-DE" smtClean="0"/>
               <a:t>Mastertitelformat bearbeiten</a:t>
             </a:r>
+            <a:endParaRPr lang="de-DE"/>
           </a:p>
         </p:txBody>
       </p:sp>
@@ -2000,9 +1978,10 @@
           </a:lstStyle>
           <a:p>
             <a:r>
-              <a:rPr lang="de-DE"/>
+              <a:rPr lang="de-DE" smtClean="0"/>
               <a:t>Master-Untertitelformat bearbeiten</a:t>
             </a:r>
+            <a:endParaRPr lang="de-DE"/>
           </a:p>
         </p:txBody>
       </p:sp>
@@ -2041,7 +2020,7 @@
               <a:pPr>
                 <a:defRPr/>
               </a:pPr>
-              <a:t>12.09.26</a:t>
+              <a:t>04.09.2024</a:t>
             </a:fld>
             <a:endParaRPr lang="de-DE" altLang="de-DE"/>
           </a:p>
@@ -2164,35 +2143,35 @@
           <a:p>
             <a:pPr lvl="0"/>
             <a:r>
-              <a:rPr lang="en-US" dirty="0"/>
+              <a:rPr lang="en-US" dirty="0" smtClean="0"/>
               <a:t>Click to edit Master text styles</a:t>
             </a:r>
           </a:p>
           <a:p>
             <a:pPr lvl="1"/>
             <a:r>
-              <a:rPr lang="en-US" dirty="0"/>
+              <a:rPr lang="en-US" dirty="0" smtClean="0"/>
               <a:t>Second level</a:t>
             </a:r>
           </a:p>
           <a:p>
             <a:pPr lvl="2"/>
             <a:r>
-              <a:rPr lang="en-US" dirty="0"/>
+              <a:rPr lang="en-US" dirty="0" smtClean="0"/>
               <a:t>Third level</a:t>
             </a:r>
           </a:p>
           <a:p>
             <a:pPr lvl="3"/>
             <a:r>
-              <a:rPr lang="en-US" dirty="0"/>
+              <a:rPr lang="en-US" dirty="0" smtClean="0"/>
               <a:t>Fourth level</a:t>
             </a:r>
           </a:p>
           <a:p>
             <a:pPr lvl="4"/>
             <a:r>
-              <a:rPr lang="en-US" dirty="0"/>
+              <a:rPr lang="en-US" dirty="0" smtClean="0"/>
               <a:t>Fifth level</a:t>
             </a:r>
             <a:endParaRPr lang="en-GB" dirty="0"/>
@@ -2357,7 +2336,7 @@
           </a:lstStyle>
           <a:p>
             <a:r>
-              <a:rPr lang="en-US" dirty="0"/>
+              <a:rPr lang="en-US" dirty="0" smtClean="0"/>
               <a:t>Click to edit Master subtitle style</a:t>
             </a:r>
             <a:endParaRPr lang="en-GB" dirty="0"/>
@@ -2629,7 +2608,7 @@
             <a:pPr algn="ctr" eaLnBrk="1" hangingPunct="1">
               <a:defRPr/>
             </a:pPr>
-            <a:endParaRPr lang="de-DE" altLang="de-DE" sz="2000">
+            <a:endParaRPr lang="de-DE" altLang="de-DE" sz="2000" smtClean="0">
               <a:latin typeface="Arial" panose="020B0604020202020204" pitchFamily="34" charset="0"/>
               <a:cs typeface="Arial" panose="020B0604020202020204" pitchFamily="34" charset="0"/>
             </a:endParaRPr>
@@ -2914,6 +2893,13 @@
     <p:sldLayoutId id="2147483781" r:id="rId6"/>
   </p:sldLayoutIdLst>
   <p:transition/>
+  <p:timing>
+    <p:tnLst>
+      <p:par>
+        <p:cTn id="1" dur="indefinite" restart="never" nodeType="tmRoot"/>
+      </p:par>
+    </p:tnLst>
+  </p:timing>
   <p:txStyles>
     <p:titleStyle>
       <a:lvl1pPr algn="l" rtl="0" eaLnBrk="0" fontAlgn="base" hangingPunct="0">
@@ -3374,11 +3360,14 @@
               <a:defRPr/>
             </a:pPr>
             <a:r>
-              <a:rPr lang="de-DE" dirty="0">
+              <a:rPr lang="de-DE" dirty="0" smtClean="0">
                 <a:sym typeface="Gill Sans" charset="0"/>
               </a:rPr>
               <a:t>Team</a:t>
             </a:r>
+            <a:endParaRPr lang="de-DE" dirty="0">
+              <a:sym typeface="Gill Sans" charset="0"/>
+            </a:endParaRPr>
           </a:p>
         </p:txBody>
       </p:sp>
@@ -3411,9 +3400,10 @@
               <a:buSzPct val="100000"/>
               <a:buFont typeface="+mj-lt"/>
               <a:defRPr/>
+              <a:buNone/>
             </a:pPr>
             <a:r>
-              <a:rPr sz="2400" b="1" dirty="0">
+              <a:rPr b="1" sz="2400">
                 <a:solidFill>
                   <a:srgbClr val="B4541E"/>
                 </a:solidFill>
@@ -3421,7 +3411,7 @@
               <a:t>APC_TDC</a:t>
             </a:r>
             <a:r>
-              <a:rPr sz="2400" b="0" dirty="0">
+              <a:rPr b="0" sz="2400">
                 <a:solidFill>
                   <a:srgbClr val="1A1A1A"/>
                 </a:solidFill>
@@ -3440,28 +3430,12 @@
               <a:buNone/>
             </a:pPr>
             <a:r>
-              <a:rPr sz="2400" b="0" dirty="0">
+              <a:rPr b="0" sz="2400">
                 <a:solidFill>
                   <a:srgbClr val="1A1A1A"/>
                 </a:solidFill>
               </a:rPr>
-              <a:t>A one-person team. </a:t>
-            </a:r>
-            <a:r>
-              <a:rPr lang="en-US" dirty="0">
-                <a:solidFill>
-                  <a:srgbClr val="1A1A1A"/>
-                </a:solidFill>
-              </a:rPr>
-              <a:t>I</a:t>
-            </a:r>
-            <a:r>
-              <a:rPr sz="2400" b="0" dirty="0">
-                <a:solidFill>
-                  <a:srgbClr val="1A1A1A"/>
-                </a:solidFill>
-              </a:rPr>
-              <a:t> entered both categories.</a:t>
+              <a:t>A one-person team. We entered both categories.</a:t>
             </a:r>
           </a:p>
           <a:p>
@@ -3471,11 +3445,6 @@
               </a:spcAft>
               <a:buNone/>
             </a:pPr>
-            <a:endParaRPr sz="2400" b="0" dirty="0">
-              <a:solidFill>
-                <a:srgbClr val="1A1A1A"/>
-              </a:solidFill>
-            </a:endParaRPr>
           </a:p>
           <a:p>
             <a:pPr>
@@ -3485,7 +3454,7 @@
               <a:buNone/>
             </a:pPr>
             <a:r>
-              <a:rPr sz="2400" b="1" dirty="0">
+              <a:rPr b="1" sz="2400">
                 <a:solidFill>
                   <a:srgbClr val="B4541E"/>
                 </a:solidFill>
@@ -3493,28 +3462,12 @@
               <a:t>Category 1</a:t>
             </a:r>
             <a:r>
-              <a:rPr sz="2400" b="0" dirty="0">
+              <a:rPr b="0" sz="2400">
                 <a:solidFill>
                   <a:srgbClr val="1A1A1A"/>
                 </a:solidFill>
               </a:rPr>
-              <a:t>  weakly supervised tool detection      </a:t>
-            </a:r>
-            <a:r>
-              <a:rPr sz="2400" b="0" dirty="0" err="1">
-                <a:solidFill>
-                  <a:srgbClr val="1A1A1A"/>
-                </a:solidFill>
-              </a:rPr>
-              <a:t>mAP</a:t>
-            </a:r>
-            <a:r>
-              <a:rPr sz="2400" b="0" dirty="0">
-                <a:solidFill>
-                  <a:srgbClr val="1A1A1A"/>
-                </a:solidFill>
-              </a:rPr>
-              <a:t>  0.4930</a:t>
+              <a:t>  weakly supervised tool detection      mAP  0.4930</a:t>
             </a:r>
           </a:p>
           <a:p>
@@ -3525,7 +3478,7 @@
               <a:buNone/>
             </a:pPr>
             <a:r>
-              <a:rPr sz="2400" b="1" dirty="0">
+              <a:rPr b="1" sz="2400">
                 <a:solidFill>
                   <a:srgbClr val="B4541E"/>
                 </a:solidFill>
@@ -3533,7 +3486,7 @@
               <a:t>Category 2</a:t>
             </a:r>
             <a:r>
-              <a:rPr sz="2400" b="0" dirty="0">
+              <a:rPr b="0" sz="2400">
                 <a:solidFill>
                   <a:srgbClr val="1A1A1A"/>
                 </a:solidFill>
@@ -3722,6 +3675,7 @@
               <a:buSzPct val="90000"/>
               <a:buFont typeface="Arial" pitchFamily="34" charset="0"/>
               <a:defRPr/>
+              <a:buNone/>
             </a:pPr>
             <a:r>
               <a:rPr sz="1400">
@@ -3745,6 +3699,13 @@
     <a:masterClrMapping/>
   </p:clrMapOvr>
   <p:transition/>
+  <p:timing>
+    <p:tnLst>
+      <p:par>
+        <p:cTn id="1" dur="indefinite" restart="never" nodeType="tmRoot"/>
+      </p:par>
+    </p:tnLst>
+  </p:timing>
 </p:sld>
 </file>
 
@@ -3789,7 +3750,7 @@
               <a:defRPr/>
             </a:pPr>
             <a:r>
-              <a:rPr lang="de-DE" dirty="0" err="1">
+              <a:rPr lang="de-DE" dirty="0" err="1" smtClean="0">
                 <a:sym typeface="Gill Sans" charset="0"/>
               </a:rPr>
               <a:t>Method</a:t>
@@ -3829,9 +3790,10 @@
               <a:buSzPct val="100000"/>
               <a:buFont typeface="+mj-lt"/>
               <a:defRPr/>
+              <a:buNone/>
             </a:pPr>
             <a:r>
-              <a:rPr sz="2000" b="1">
+              <a:rPr b="1" sz="2000">
                 <a:solidFill>
                   <a:srgbClr val="B4541E"/>
                 </a:solidFill>
@@ -3839,7 +3801,7 @@
               <a:t>The labels we are given are tool presence, not boxes.</a:t>
             </a:r>
             <a:r>
-              <a:rPr sz="2000" b="0">
+              <a:rPr b="0" sz="2000">
                 <a:solidFill>
                   <a:srgbClr val="1A1A1A"/>
                 </a:solidFill>
@@ -3861,7 +3823,7 @@
           <p:nvPr/>
         </p:nvPicPr>
         <p:blipFill>
-          <a:blip r:embed="rId3"/>
+          <a:blip r:embed="rId2"/>
           <a:stretch>
             <a:fillRect/>
           </a:stretch>
@@ -3905,7 +3867,7 @@
               <a:buNone/>
             </a:pPr>
             <a:r>
-              <a:rPr sz="1600" b="1">
+              <a:rPr b="1" sz="1600">
                 <a:solidFill>
                   <a:srgbClr val="B4541E"/>
                 </a:solidFill>
@@ -3913,7 +3875,7 @@
               <a:t>Accept a frame only if</a:t>
             </a:r>
             <a:r>
-              <a:rPr sz="1600" b="0">
+              <a:rPr b="0" sz="1600">
                 <a:solidFill>
                   <a:srgbClr val="1A1A1A"/>
                 </a:solidFill>
@@ -3934,6 +3896,13 @@
     <a:masterClrMapping/>
   </p:clrMapOvr>
   <p:transition/>
+  <p:timing>
+    <p:tnLst>
+      <p:par>
+        <p:cTn id="1" dur="indefinite" restart="never" nodeType="tmRoot"/>
+      </p:par>
+    </p:tnLst>
+  </p:timing>
 </p:sld>
 </file>
 
@@ -3978,13 +3947,13 @@
               <a:defRPr/>
             </a:pPr>
             <a:r>
-              <a:rPr lang="de-DE" dirty="0">
+              <a:rPr lang="de-DE" dirty="0" smtClean="0">
                 <a:sym typeface="Gill Sans" charset="0"/>
               </a:rPr>
               <a:t>Key design </a:t>
             </a:r>
             <a:r>
-              <a:rPr lang="de-DE" dirty="0" err="1">
+              <a:rPr lang="de-DE" dirty="0" err="1" smtClean="0">
                 <a:sym typeface="Gill Sans" charset="0"/>
               </a:rPr>
               <a:t>decisions</a:t>
@@ -4024,9 +3993,10 @@
               <a:buSzPct val="100000"/>
               <a:buFont typeface="+mj-lt"/>
               <a:defRPr/>
+              <a:buNone/>
             </a:pPr>
             <a:r>
-              <a:rPr sz="2000" b="1">
+              <a:rPr b="1" sz="2000">
                 <a:solidFill>
                   <a:srgbClr val="B4541E"/>
                 </a:solidFill>
@@ -4034,7 +4004,7 @@
               <a:t>1.  Scale beats recipe.</a:t>
             </a:r>
             <a:r>
-              <a:rPr sz="2000" b="0">
+              <a:rPr b="0" sz="2000">
                 <a:solidFill>
                   <a:srgbClr val="1A1A1A"/>
                 </a:solidFill>
@@ -4053,7 +4023,7 @@
               <a:buNone/>
             </a:pPr>
             <a:r>
-              <a:rPr sz="2000" b="1">
+              <a:rPr b="1" sz="2000">
                 <a:solidFill>
                   <a:srgbClr val="B4541E"/>
                 </a:solidFill>
@@ -4061,7 +4031,7 @@
               <a:t>2.  Let the weak label do the filtering.</a:t>
             </a:r>
             <a:r>
-              <a:rPr sz="2000" b="0">
+              <a:rPr b="0" sz="2000">
                 <a:solidFill>
                   <a:srgbClr val="1A1A1A"/>
                 </a:solidFill>
@@ -4077,7 +4047,7 @@
               <a:buNone/>
             </a:pPr>
             <a:r>
-              <a:rPr sz="2000" b="1">
+              <a:rPr b="1" sz="2000">
                 <a:solidFill>
                   <a:srgbClr val="B4541E"/>
                 </a:solidFill>
@@ -4085,7 +4055,7 @@
               <a:t>3.  Never size-filter pseudo-labels.</a:t>
             </a:r>
             <a:r>
-              <a:rPr sz="2000" b="0">
+              <a:rPr b="0" sz="2000">
                 <a:solidFill>
                   <a:srgbClr val="1A1A1A"/>
                 </a:solidFill>
@@ -4101,7 +4071,7 @@
               <a:buNone/>
             </a:pPr>
             <a:r>
-              <a:rPr sz="2000" b="1">
+              <a:rPr b="1" sz="2000">
                 <a:solidFill>
                   <a:srgbClr val="B4541E"/>
                 </a:solidFill>
@@ -4109,7 +4079,7 @@
               <a:t>4.  Never keep a frame whose visible tool has no box.</a:t>
             </a:r>
             <a:r>
-              <a:rPr sz="2000" b="0">
+              <a:rPr b="0" sz="2000">
                 <a:solidFill>
                   <a:srgbClr val="1A1A1A"/>
                 </a:solidFill>
@@ -4125,7 +4095,7 @@
               <a:buNone/>
             </a:pPr>
             <a:r>
-              <a:rPr sz="2000" b="1">
+              <a:rPr b="1" sz="2000">
                 <a:solidFill>
                   <a:srgbClr val="B4541E"/>
                 </a:solidFill>
@@ -4133,12 +4103,12 @@
               <a:t>5.  The remaining headroom is AP75, not recall.</a:t>
             </a:r>
             <a:r>
-              <a:rPr sz="2000" b="0">
+              <a:rPr b="0" sz="2000">
                 <a:solidFill>
                   <a:srgbClr val="1A1A1A"/>
                 </a:solidFill>
               </a:rPr>
-              <a:t>  Common classes already sit at AP50 0.93. Training at 800 px: +0.0275 AP75. Fusing the 640 and 800 models: +0.0376.</a:t>
+              <a:t>  Needle driver sits at AP50 0.93 but AP75 0.51. Training at 800 px: +0.0275 AP75. Two-model fusion: +0.0376 AP75, measured on a pair of 640 px models. Our submission fuses 640 with 800, a combination we could not measure locally.</a:t>
             </a:r>
           </a:p>
         </p:txBody>
@@ -4154,6 +4124,13 @@
     <a:masterClrMapping/>
   </p:clrMapOvr>
   <p:transition/>
+  <p:timing>
+    <p:tnLst>
+      <p:par>
+        <p:cTn id="1" dur="indefinite" restart="never" nodeType="tmRoot"/>
+      </p:par>
+    </p:tnLst>
+  </p:timing>
 </p:sld>
 </file>
 
@@ -4198,41 +4175,44 @@
               <a:defRPr/>
             </a:pPr>
             <a:r>
-              <a:rPr lang="de-DE" dirty="0" err="1">
+              <a:rPr lang="de-DE" dirty="0" err="1" smtClean="0">
                 <a:sym typeface="Gill Sans" charset="0"/>
               </a:rPr>
               <a:t>What</a:t>
             </a:r>
             <a:r>
-              <a:rPr lang="de-DE" dirty="0">
+              <a:rPr lang="de-DE" dirty="0" smtClean="0">
                 <a:sym typeface="Gill Sans" charset="0"/>
               </a:rPr>
               <a:t> </a:t>
             </a:r>
             <a:r>
-              <a:rPr lang="de-DE" dirty="0" err="1">
+              <a:rPr lang="de-DE" dirty="0" err="1" smtClean="0">
                 <a:sym typeface="Gill Sans" charset="0"/>
               </a:rPr>
               <a:t>did</a:t>
             </a:r>
             <a:r>
-              <a:rPr lang="de-DE" dirty="0">
+              <a:rPr lang="de-DE" dirty="0" smtClean="0">
                 <a:sym typeface="Gill Sans" charset="0"/>
               </a:rPr>
               <a:t> not </a:t>
             </a:r>
             <a:r>
-              <a:rPr lang="de-DE" dirty="0" err="1">
+              <a:rPr lang="de-DE" dirty="0" err="1" smtClean="0">
                 <a:sym typeface="Gill Sans" charset="0"/>
               </a:rPr>
               <a:t>work</a:t>
             </a:r>
             <a:r>
-              <a:rPr lang="de-DE" dirty="0">
+              <a:rPr lang="de-DE" dirty="0" smtClean="0">
                 <a:sym typeface="Gill Sans" charset="0"/>
               </a:rPr>
               <a:t>?</a:t>
             </a:r>
+            <a:endParaRPr lang="de-DE" dirty="0">
+              <a:sym typeface="Gill Sans" charset="0"/>
+            </a:endParaRPr>
           </a:p>
         </p:txBody>
       </p:sp>
@@ -4265,9 +4245,10 @@
               <a:buSzPct val="100000"/>
               <a:buFont typeface="+mj-lt"/>
               <a:defRPr/>
+              <a:buNone/>
             </a:pPr>
             <a:r>
-              <a:rPr sz="1900" b="1">
+              <a:rPr b="1" sz="1900">
                 <a:solidFill>
                   <a:srgbClr val="B4541E"/>
                 </a:solidFill>
@@ -4275,7 +4256,7 @@
               <a:t>Inference-time search.</a:t>
             </a:r>
             <a:r>
-              <a:rPr sz="1900" b="0">
+              <a:rPr b="0" sz="1900">
                 <a:solidFill>
                   <a:srgbClr val="1A1A1A"/>
                 </a:solidFill>
@@ -4294,7 +4275,7 @@
               <a:buNone/>
             </a:pPr>
             <a:r>
-              <a:rPr sz="1900" b="1">
+              <a:rPr b="1" sz="1900">
                 <a:solidFill>
                   <a:srgbClr val="B4541E"/>
                 </a:solidFill>
@@ -4302,7 +4283,7 @@
               <a:t>Temporal post-processing.</a:t>
             </a:r>
             <a:r>
-              <a:rPr sz="1900" b="0">
+              <a:rPr b="0" sz="1900">
                 <a:solidFill>
                   <a:srgbClr val="1A1A1A"/>
                 </a:solidFill>
@@ -4318,7 +4299,7 @@
               <a:buNone/>
             </a:pPr>
             <a:r>
-              <a:rPr sz="1900" b="1">
+              <a:rPr b="1" sz="1900">
                 <a:solidFill>
                   <a:srgbClr val="B4541E"/>
                 </a:solidFill>
@@ -4326,7 +4307,7 @@
               <a:t>Training on the official ground truth alone.</a:t>
             </a:r>
             <a:r>
-              <a:rPr sz="1900" b="0">
+              <a:rPr b="0" sz="1900">
                 <a:solidFill>
                   <a:srgbClr val="1A1A1A"/>
                 </a:solidFill>
@@ -4342,7 +4323,7 @@
               <a:buNone/>
             </a:pPr>
             <a:r>
-              <a:rPr sz="1900" b="1">
+              <a:rPr b="1" sz="1900">
                 <a:solidFill>
                   <a:srgbClr val="B4541E"/>
                 </a:solidFill>
@@ -4350,7 +4331,7 @@
               <a:t>Reading the robot interface with OCR to relabel.</a:t>
             </a:r>
             <a:r>
-              <a:rPr sz="1900" b="0">
+              <a:rPr b="0" sz="1900">
                 <a:solidFill>
                   <a:srgbClr val="1A1A1A"/>
                 </a:solidFill>
@@ -4366,7 +4347,7 @@
               <a:buNone/>
             </a:pPr>
             <a:r>
-              <a:rPr sz="1900" b="1">
+              <a:rPr b="1" sz="1900">
                 <a:solidFill>
                   <a:srgbClr val="B4541E"/>
                 </a:solidFill>
@@ -4374,7 +4355,7 @@
               <a:t>Trusting a proxy metric.</a:t>
             </a:r>
             <a:r>
-              <a:rPr sz="1900" b="0">
+              <a:rPr b="0" sz="1900">
                 <a:solidFill>
                   <a:srgbClr val="1A1A1A"/>
                 </a:solidFill>
@@ -4389,11 +4370,6 @@
               </a:spcAft>
               <a:buNone/>
             </a:pPr>
-            <a:endParaRPr sz="1900" b="0">
-              <a:solidFill>
-                <a:srgbClr val="1A1A1A"/>
-              </a:solidFill>
-            </a:endParaRPr>
           </a:p>
           <a:p>
             <a:pPr>
@@ -4403,7 +4379,7 @@
               <a:buNone/>
             </a:pPr>
             <a:r>
-              <a:rPr sz="1900" b="1">
+              <a:rPr b="1" sz="1900">
                 <a:solidFill>
                   <a:srgbClr val="B4541E"/>
                 </a:solidFill>
@@ -4411,7 +4387,7 @@
               <a:t>And the honest caveat:</a:t>
             </a:r>
             <a:r>
-              <a:rPr sz="1900" b="0">
+              <a:rPr b="0" sz="1900">
                 <a:solidFill>
                   <a:srgbClr val="1A1A1A"/>
                 </a:solidFill>
@@ -4432,6 +4408,13 @@
     <a:masterClrMapping/>
   </p:clrMapOvr>
   <p:transition/>
+  <p:timing>
+    <p:tnLst>
+      <p:par>
+        <p:cTn id="1" dur="indefinite" restart="never" nodeType="tmRoot"/>
+      </p:par>
+    </p:tnLst>
+  </p:timing>
 </p:sld>
 </file>
 

</xml_diff>